<commit_message>
Update free book PDF and Chris Bryce presentation
</commit_message>
<xml_diff>
--- a/pptx/presentations/chris-bryce-livestream-2-2026-03-12.pptx
+++ b/pptx/presentations/chris-bryce-livestream-2-2026-03-12.pptx
@@ -3668,24 +3668,28 @@
           <a:p>
             <a:pPr lvl="0"/>
             <a:r>
+              <a:rPr dirty="0"/>
               <a:t>Agencies that fix this first become the experts who sell the fix</a:t>
             </a:r>
           </a:p>
           <a:p>
             <a:pPr lvl="0"/>
             <a:r>
+              <a:rPr dirty="0"/>
               <a:t>White-label MX audit under your own brand</a:t>
             </a:r>
           </a:p>
           <a:p>
             <a:pPr lvl="0"/>
             <a:r>
+              <a:rPr dirty="0"/>
               <a:t>Fix your own site first — it becomes the case study</a:t>
             </a:r>
           </a:p>
           <a:p>
             <a:pPr lvl="0"/>
             <a:r>
+              <a:rPr dirty="0"/>
               <a:t>Clients are already asking about AI readiness</a:t>
             </a:r>
           </a:p>

</xml_diff>